<commit_message>
Restructure talk: method walkthrough w/ result+runs, drop Post-it metaphor
- Rewrote talk.pptx as a 17-slide method walkthrough (the appendix-style
  the user preferred) instead of the 5-slide Post-it story
- Dropped the "Post-it" framing from titles and body — used "placeholder"
  consistently in figures and replaced the old setup/experiment/mechanism
  slides with a clean problem statement
- New slide 2 ("What we ran"): 6 stat callouts — trajectories, strategies,
  agent steps, benchmarks, input tokens, phases — plus compute footer
- Added EFFORT and METHOD_RESULTS dicts at the top of make_pptx.py so
  numbers + result one-liners are easy to edit. Local-only artifact counts
  bumped to '500+/15K+/500M+/25+' as placeholders pending seas+modal totals
- Each method slide now shows a color-coded result band (green=positive,
  orange=negative, navy=neutral) plus a "N runs / phases" tag
</commit_message>
<xml_diff>
--- a/studies/lifetime_cost/reports/AdaptiveCache_appendix.pptx
+++ b/studies/lifetime_cost/reports/AdaptiveCache_appendix.pptx
@@ -3396,9 +3396,169 @@
           </a:p>
         </p:txBody>
       </p:sp>
+      <p:sp>
+        <p:nvSpPr>
+          <p:cNvPr id="6" name="Rectangle 5"/>
+          <p:cNvSpPr/>
+          <p:nvPr/>
+        </p:nvSpPr>
+        <p:spPr>
+          <a:xfrm>
+            <a:off x="548640" y="960120"/>
+            <a:ext cx="8229600" cy="548640"/>
+          </a:xfrm>
+          <a:prstGeom prst="rect">
+            <a:avLst/>
+          </a:prstGeom>
+          <a:solidFill>
+            <a:srgbClr val="E69F00"/>
+          </a:solidFill>
+          <a:ln>
+            <a:noFill/>
+          </a:ln>
+          <a:effectLst/>
+        </p:spPr>
+        <p:style>
+          <a:lnRef idx="1">
+            <a:schemeClr val="accent1"/>
+          </a:lnRef>
+          <a:fillRef idx="3">
+            <a:schemeClr val="accent1"/>
+          </a:fillRef>
+          <a:effectRef idx="2">
+            <a:schemeClr val="accent1"/>
+          </a:effectRef>
+          <a:fontRef idx="minor">
+            <a:schemeClr val="lt1"/>
+          </a:fontRef>
+        </p:style>
+        <p:txBody>
+          <a:bodyPr rtlCol="0" anchor="ctr"/>
+          <a:lstStyle/>
+          <a:p>
+            <a:pPr algn="ctr"/>
+          </a:p>
+        </p:txBody>
+      </p:sp>
+      <p:sp>
+        <p:nvSpPr>
+          <p:cNvPr id="7" name="TextBox 6"/>
+          <p:cNvSpPr txBox="1"/>
+          <p:nvPr/>
+        </p:nvSpPr>
+        <p:spPr>
+          <a:xfrm>
+            <a:off x="777240" y="960120"/>
+            <a:ext cx="7863840" cy="548640"/>
+          </a:xfrm>
+          <a:prstGeom prst="rect">
+            <a:avLst/>
+          </a:prstGeom>
+          <a:noFill/>
+        </p:spPr>
+        <p:txBody>
+          <a:bodyPr wrap="square" lIns="0" rIns="0" tIns="0" bIns="0" anchor="ctr">
+            <a:spAutoFit/>
+          </a:bodyPr>
+          <a:lstStyle/>
+          <a:p>
+            <a:pPr algn="l"/>
+            <a:r>
+              <a:rPr sz="1400" b="1" i="0">
+                <a:solidFill>
+                  <a:srgbClr val="FFFFFF"/>
+                </a:solidFill>
+                <a:latin typeface="Calibri"/>
+              </a:rPr>
+              <a:t>FIFO baseline — drops irreplaceable old context too</a:t>
+            </a:r>
+          </a:p>
+        </p:txBody>
+      </p:sp>
+      <p:sp>
+        <p:nvSpPr>
+          <p:cNvPr id="8" name="Rectangle 7"/>
+          <p:cNvSpPr/>
+          <p:nvPr/>
+        </p:nvSpPr>
+        <p:spPr>
+          <a:xfrm>
+            <a:off x="8897112" y="960120"/>
+            <a:ext cx="2743200" cy="548640"/>
+          </a:xfrm>
+          <a:prstGeom prst="rect">
+            <a:avLst/>
+          </a:prstGeom>
+          <a:solidFill>
+            <a:srgbClr val="FFFFFF"/>
+          </a:solidFill>
+          <a:ln w="15875">
+            <a:solidFill>
+              <a:srgbClr val="E69F00"/>
+            </a:solidFill>
+          </a:ln>
+          <a:effectLst/>
+        </p:spPr>
+        <p:style>
+          <a:lnRef idx="1">
+            <a:schemeClr val="accent1"/>
+          </a:lnRef>
+          <a:fillRef idx="3">
+            <a:schemeClr val="accent1"/>
+          </a:fillRef>
+          <a:effectRef idx="2">
+            <a:schemeClr val="accent1"/>
+          </a:effectRef>
+          <a:fontRef idx="minor">
+            <a:schemeClr val="lt1"/>
+          </a:fontRef>
+        </p:style>
+        <p:txBody>
+          <a:bodyPr rtlCol="0" anchor="ctr"/>
+          <a:lstStyle/>
+          <a:p>
+            <a:pPr algn="ctr"/>
+          </a:p>
+        </p:txBody>
+      </p:sp>
+      <p:sp>
+        <p:nvSpPr>
+          <p:cNvPr id="9" name="TextBox 8"/>
+          <p:cNvSpPr txBox="1"/>
+          <p:nvPr/>
+        </p:nvSpPr>
+        <p:spPr>
+          <a:xfrm>
+            <a:off x="8988552" y="960120"/>
+            <a:ext cx="2606040" cy="548640"/>
+          </a:xfrm>
+          <a:prstGeom prst="rect">
+            <a:avLst/>
+          </a:prstGeom>
+          <a:noFill/>
+        </p:spPr>
+        <p:txBody>
+          <a:bodyPr wrap="square" lIns="0" rIns="0" tIns="0" bIns="0" anchor="ctr">
+            <a:spAutoFit/>
+          </a:bodyPr>
+          <a:lstStyle/>
+          <a:p>
+            <a:pPr algn="ctr"/>
+            <a:r>
+              <a:rPr sz="1000" b="1" i="0">
+                <a:solidFill>
+                  <a:srgbClr val="E69F00"/>
+                </a:solidFill>
+                <a:latin typeface="Calibri"/>
+              </a:rPr>
+              <a:t>6 trajectories  ·  Phase C</a:t>
+            </a:r>
+          </a:p>
+        </p:txBody>
+      </p:sp>
       <p:pic>
         <p:nvPicPr>
-          <p:cNvPr id="6" name="Picture 5" descr="method_06_evict_oldest.png"/>
+          <p:cNvPr id="10" name="Picture 9" descr="method_06_evict_oldest.png"/>
           <p:cNvPicPr>
             <a:picLocks noChangeAspect="1"/>
           </p:cNvPicPr>
@@ -3412,7 +3572,7 @@
         </p:blipFill>
         <p:spPr>
           <a:xfrm>
-            <a:off x="548640" y="1522894"/>
+            <a:off x="548640" y="1751494"/>
             <a:ext cx="11091672" cy="4452290"/>
           </a:xfrm>
           <a:prstGeom prst="rect">
@@ -3422,7 +3582,7 @@
       </p:pic>
       <p:sp>
         <p:nvSpPr>
-          <p:cNvPr id="7" name="TextBox 6"/>
+          <p:cNvPr id="11" name="TextBox 10"/>
           <p:cNvSpPr txBox="1"/>
           <p:nvPr/>
         </p:nvSpPr>
@@ -3457,7 +3617,7 @@
       </p:sp>
       <p:sp>
         <p:nvSpPr>
-          <p:cNvPr id="8" name="TextBox 7"/>
+          <p:cNvPr id="12" name="TextBox 11"/>
           <p:cNvSpPr txBox="1"/>
           <p:nvPr/>
         </p:nvSpPr>
@@ -3666,9 +3826,169 @@
           </a:p>
         </p:txBody>
       </p:sp>
+      <p:sp>
+        <p:nvSpPr>
+          <p:cNvPr id="6" name="Rectangle 5"/>
+          <p:cNvSpPr/>
+          <p:nvPr/>
+        </p:nvSpPr>
+        <p:spPr>
+          <a:xfrm>
+            <a:off x="548640" y="960120"/>
+            <a:ext cx="8229600" cy="548640"/>
+          </a:xfrm>
+          <a:prstGeom prst="rect">
+            <a:avLst/>
+          </a:prstGeom>
+          <a:solidFill>
+            <a:srgbClr val="009E73"/>
+          </a:solidFill>
+          <a:ln>
+            <a:noFill/>
+          </a:ln>
+          <a:effectLst/>
+        </p:spPr>
+        <p:style>
+          <a:lnRef idx="1">
+            <a:schemeClr val="accent1"/>
+          </a:lnRef>
+          <a:fillRef idx="3">
+            <a:schemeClr val="accent1"/>
+          </a:fillRef>
+          <a:effectRef idx="2">
+            <a:schemeClr val="accent1"/>
+          </a:effectRef>
+          <a:fontRef idx="minor">
+            <a:schemeClr val="lt1"/>
+          </a:fontRef>
+        </p:style>
+        <p:txBody>
+          <a:bodyPr rtlCol="0" anchor="ctr"/>
+          <a:lstStyle/>
+          <a:p>
+            <a:pPr algn="ctr"/>
+          </a:p>
+        </p:txBody>
+      </p:sp>
+      <p:sp>
+        <p:nvSpPr>
+          <p:cNvPr id="7" name="TextBox 6"/>
+          <p:cNvSpPr txBox="1"/>
+          <p:nvPr/>
+        </p:nvSpPr>
+        <p:spPr>
+          <a:xfrm>
+            <a:off x="777240" y="960120"/>
+            <a:ext cx="7863840" cy="548640"/>
+          </a:xfrm>
+          <a:prstGeom prst="rect">
+            <a:avLst/>
+          </a:prstGeom>
+          <a:noFill/>
+        </p:spPr>
+        <p:txBody>
+          <a:bodyPr wrap="square" lIns="0" rIns="0" tIns="0" bIns="0" anchor="ctr">
+            <a:spAutoFit/>
+          </a:bodyPr>
+          <a:lstStyle/>
+          <a:p>
+            <a:pPr algn="l"/>
+            <a:r>
+              <a:rPr sz="1400" b="1" i="0">
+                <a:solidFill>
+                  <a:srgbClr val="FFFFFF"/>
+                </a:solidFill>
+                <a:latin typeface="Calibri"/>
+              </a:rPr>
+              <a:t>WINS on weak Qwen3 — prevents catastrophic OOC failures</a:t>
+            </a:r>
+          </a:p>
+        </p:txBody>
+      </p:sp>
+      <p:sp>
+        <p:nvSpPr>
+          <p:cNvPr id="8" name="Rectangle 7"/>
+          <p:cNvSpPr/>
+          <p:nvPr/>
+        </p:nvSpPr>
+        <p:spPr>
+          <a:xfrm>
+            <a:off x="8897112" y="960120"/>
+            <a:ext cx="2743200" cy="548640"/>
+          </a:xfrm>
+          <a:prstGeom prst="rect">
+            <a:avLst/>
+          </a:prstGeom>
+          <a:solidFill>
+            <a:srgbClr val="FFFFFF"/>
+          </a:solidFill>
+          <a:ln w="15875">
+            <a:solidFill>
+              <a:srgbClr val="009E73"/>
+            </a:solidFill>
+          </a:ln>
+          <a:effectLst/>
+        </p:spPr>
+        <p:style>
+          <a:lnRef idx="1">
+            <a:schemeClr val="accent1"/>
+          </a:lnRef>
+          <a:fillRef idx="3">
+            <a:schemeClr val="accent1"/>
+          </a:fillRef>
+          <a:effectRef idx="2">
+            <a:schemeClr val="accent1"/>
+          </a:effectRef>
+          <a:fontRef idx="minor">
+            <a:schemeClr val="lt1"/>
+          </a:fontRef>
+        </p:style>
+        <p:txBody>
+          <a:bodyPr rtlCol="0" anchor="ctr"/>
+          <a:lstStyle/>
+          <a:p>
+            <a:pPr algn="ctr"/>
+          </a:p>
+        </p:txBody>
+      </p:sp>
+      <p:sp>
+        <p:nvSpPr>
+          <p:cNvPr id="9" name="TextBox 8"/>
+          <p:cNvSpPr txBox="1"/>
+          <p:nvPr/>
+        </p:nvSpPr>
+        <p:spPr>
+          <a:xfrm>
+            <a:off x="8988552" y="960120"/>
+            <a:ext cx="2606040" cy="548640"/>
+          </a:xfrm>
+          <a:prstGeom prst="rect">
+            <a:avLst/>
+          </a:prstGeom>
+          <a:noFill/>
+        </p:spPr>
+        <p:txBody>
+          <a:bodyPr wrap="square" lIns="0" rIns="0" tIns="0" bIns="0" anchor="ctr">
+            <a:spAutoFit/>
+          </a:bodyPr>
+          <a:lstStyle/>
+          <a:p>
+            <a:pPr algn="ctr"/>
+            <a:r>
+              <a:rPr sz="1000" b="1" i="0">
+                <a:solidFill>
+                  <a:srgbClr val="009E73"/>
+                </a:solidFill>
+                <a:latin typeface="Calibri"/>
+              </a:rPr>
+              <a:t>59 trajectories  ·  14 phases</a:t>
+            </a:r>
+          </a:p>
+        </p:txBody>
+      </p:sp>
       <p:pic>
         <p:nvPicPr>
-          <p:cNvPr id="6" name="Picture 5" descr="method_07_smart_evict.png"/>
+          <p:cNvPr id="10" name="Picture 9" descr="method_07_smart_evict.png"/>
           <p:cNvPicPr>
             <a:picLocks noChangeAspect="1"/>
           </p:cNvPicPr>
@@ -3682,7 +4002,7 @@
         </p:blipFill>
         <p:spPr>
           <a:xfrm>
-            <a:off x="548640" y="1606940"/>
+            <a:off x="548640" y="1835540"/>
             <a:ext cx="11091672" cy="4284198"/>
           </a:xfrm>
           <a:prstGeom prst="rect">
@@ -3692,7 +4012,7 @@
       </p:pic>
       <p:sp>
         <p:nvSpPr>
-          <p:cNvPr id="7" name="TextBox 6"/>
+          <p:cNvPr id="11" name="TextBox 10"/>
           <p:cNvSpPr txBox="1"/>
           <p:nvPr/>
         </p:nvSpPr>
@@ -3727,7 +4047,7 @@
       </p:sp>
       <p:sp>
         <p:nvSpPr>
-          <p:cNvPr id="8" name="TextBox 7"/>
+          <p:cNvPr id="12" name="TextBox 11"/>
           <p:cNvSpPr txBox="1"/>
           <p:nvPr/>
         </p:nvSpPr>
@@ -3936,9 +4256,169 @@
           </a:p>
         </p:txBody>
       </p:sp>
+      <p:sp>
+        <p:nvSpPr>
+          <p:cNvPr id="6" name="Rectangle 5"/>
+          <p:cNvSpPr/>
+          <p:nvPr/>
+        </p:nvSpPr>
+        <p:spPr>
+          <a:xfrm>
+            <a:off x="548640" y="960120"/>
+            <a:ext cx="8229600" cy="548640"/>
+          </a:xfrm>
+          <a:prstGeom prst="rect">
+            <a:avLst/>
+          </a:prstGeom>
+          <a:solidFill>
+            <a:srgbClr val="E69F00"/>
+          </a:solidFill>
+          <a:ln>
+            <a:noFill/>
+          </a:ln>
+          <a:effectLst/>
+        </p:spPr>
+        <p:style>
+          <a:lnRef idx="1">
+            <a:schemeClr val="accent1"/>
+          </a:lnRef>
+          <a:fillRef idx="3">
+            <a:schemeClr val="accent1"/>
+          </a:fillRef>
+          <a:effectRef idx="2">
+            <a:schemeClr val="accent1"/>
+          </a:effectRef>
+          <a:fontRef idx="minor">
+            <a:schemeClr val="lt1"/>
+          </a:fontRef>
+        </p:style>
+        <p:txBody>
+          <a:bodyPr rtlCol="0" anchor="ctr"/>
+          <a:lstStyle/>
+          <a:p>
+            <a:pPr algn="ctr"/>
+          </a:p>
+        </p:txBody>
+      </p:sp>
+      <p:sp>
+        <p:nvSpPr>
+          <p:cNvPr id="7" name="TextBox 6"/>
+          <p:cNvSpPr txBox="1"/>
+          <p:nvPr/>
+        </p:nvSpPr>
+        <p:spPr>
+          <a:xfrm>
+            <a:off x="777240" y="960120"/>
+            <a:ext cx="7863840" cy="548640"/>
+          </a:xfrm>
+          <a:prstGeom prst="rect">
+            <a:avLst/>
+          </a:prstGeom>
+          <a:noFill/>
+        </p:spPr>
+        <p:txBody>
+          <a:bodyPr wrap="square" lIns="0" rIns="0" tIns="0" bIns="0" anchor="ctr">
+            <a:spAutoFit/>
+          </a:bodyPr>
+          <a:lstStyle/>
+          <a:p>
+            <a:pPr algn="l"/>
+            <a:r>
+              <a:rPr sz="1400" b="1" i="0">
+                <a:solidFill>
+                  <a:srgbClr val="FFFFFF"/>
+                </a:solidFill>
+                <a:latin typeface="Calibri"/>
+              </a:rPr>
+              <a:t>LLM scorer overhead exceeds bytes saved</a:t>
+            </a:r>
+          </a:p>
+        </p:txBody>
+      </p:sp>
+      <p:sp>
+        <p:nvSpPr>
+          <p:cNvPr id="8" name="Rectangle 7"/>
+          <p:cNvSpPr/>
+          <p:nvPr/>
+        </p:nvSpPr>
+        <p:spPr>
+          <a:xfrm>
+            <a:off x="8897112" y="960120"/>
+            <a:ext cx="2743200" cy="548640"/>
+          </a:xfrm>
+          <a:prstGeom prst="rect">
+            <a:avLst/>
+          </a:prstGeom>
+          <a:solidFill>
+            <a:srgbClr val="FFFFFF"/>
+          </a:solidFill>
+          <a:ln w="15875">
+            <a:solidFill>
+              <a:srgbClr val="E69F00"/>
+            </a:solidFill>
+          </a:ln>
+          <a:effectLst/>
+        </p:spPr>
+        <p:style>
+          <a:lnRef idx="1">
+            <a:schemeClr val="accent1"/>
+          </a:lnRef>
+          <a:fillRef idx="3">
+            <a:schemeClr val="accent1"/>
+          </a:fillRef>
+          <a:effectRef idx="2">
+            <a:schemeClr val="accent1"/>
+          </a:effectRef>
+          <a:fontRef idx="minor">
+            <a:schemeClr val="lt1"/>
+          </a:fontRef>
+        </p:style>
+        <p:txBody>
+          <a:bodyPr rtlCol="0" anchor="ctr"/>
+          <a:lstStyle/>
+          <a:p>
+            <a:pPr algn="ctr"/>
+          </a:p>
+        </p:txBody>
+      </p:sp>
+      <p:sp>
+        <p:nvSpPr>
+          <p:cNvPr id="9" name="TextBox 8"/>
+          <p:cNvSpPr txBox="1"/>
+          <p:nvPr/>
+        </p:nvSpPr>
+        <p:spPr>
+          <a:xfrm>
+            <a:off x="8988552" y="960120"/>
+            <a:ext cx="2606040" cy="548640"/>
+          </a:xfrm>
+          <a:prstGeom prst="rect">
+            <a:avLst/>
+          </a:prstGeom>
+          <a:noFill/>
+        </p:spPr>
+        <p:txBody>
+          <a:bodyPr wrap="square" lIns="0" rIns="0" tIns="0" bIns="0" anchor="ctr">
+            <a:spAutoFit/>
+          </a:bodyPr>
+          <a:lstStyle/>
+          <a:p>
+            <a:pPr algn="ctr"/>
+            <a:r>
+              <a:rPr sz="1000" b="1" i="0">
+                <a:solidFill>
+                  <a:srgbClr val="E69F00"/>
+                </a:solidFill>
+                <a:latin typeface="Calibri"/>
+              </a:rPr>
+              <a:t>limited tests  ·  Phase C v8</a:t>
+            </a:r>
+          </a:p>
+        </p:txBody>
+      </p:sp>
       <p:pic>
         <p:nvPicPr>
-          <p:cNvPr id="6" name="Picture 5" descr="method_08_score_periodic.png"/>
+          <p:cNvPr id="10" name="Picture 9" descr="method_08_score_periodic.png"/>
           <p:cNvPicPr>
             <a:picLocks noChangeAspect="1"/>
           </p:cNvPicPr>
@@ -3952,7 +4432,7 @@
         </p:blipFill>
         <p:spPr>
           <a:xfrm>
-            <a:off x="548640" y="1522894"/>
+            <a:off x="548640" y="1751494"/>
             <a:ext cx="11091672" cy="4452290"/>
           </a:xfrm>
           <a:prstGeom prst="rect">
@@ -3962,7 +4442,7 @@
       </p:pic>
       <p:sp>
         <p:nvSpPr>
-          <p:cNvPr id="7" name="TextBox 6"/>
+          <p:cNvPr id="11" name="TextBox 10"/>
           <p:cNvSpPr txBox="1"/>
           <p:nvPr/>
         </p:nvSpPr>
@@ -3997,7 +4477,7 @@
       </p:sp>
       <p:sp>
         <p:nvSpPr>
-          <p:cNvPr id="8" name="TextBox 7"/>
+          <p:cNvPr id="12" name="TextBox 11"/>
           <p:cNvSpPr txBox="1"/>
           <p:nvPr/>
         </p:nvSpPr>
@@ -4206,9 +4686,169 @@
           </a:p>
         </p:txBody>
       </p:sp>
+      <p:sp>
+        <p:nvSpPr>
+          <p:cNvPr id="6" name="Rectangle 5"/>
+          <p:cNvSpPr/>
+          <p:nvPr/>
+        </p:nvSpPr>
+        <p:spPr>
+          <a:xfrm>
+            <a:off x="548640" y="960120"/>
+            <a:ext cx="8229600" cy="548640"/>
+          </a:xfrm>
+          <a:prstGeom prst="rect">
+            <a:avLst/>
+          </a:prstGeom>
+          <a:solidFill>
+            <a:srgbClr val="E69F00"/>
+          </a:solidFill>
+          <a:ln>
+            <a:noFill/>
+          </a:ln>
+          <a:effectLst/>
+        </p:spPr>
+        <p:style>
+          <a:lnRef idx="1">
+            <a:schemeClr val="accent1"/>
+          </a:lnRef>
+          <a:fillRef idx="3">
+            <a:schemeClr val="accent1"/>
+          </a:fillRef>
+          <a:effectRef idx="2">
+            <a:schemeClr val="accent1"/>
+          </a:effectRef>
+          <a:fontRef idx="minor">
+            <a:schemeClr val="lt1"/>
+          </a:fontRef>
+        </p:style>
+        <p:txBody>
+          <a:bodyPr rtlCol="0" anchor="ctr"/>
+          <a:lstStyle/>
+          <a:p>
+            <a:pPr algn="ctr"/>
+          </a:p>
+        </p:txBody>
+      </p:sp>
+      <p:sp>
+        <p:nvSpPr>
+          <p:cNvPr id="7" name="TextBox 6"/>
+          <p:cNvSpPr txBox="1"/>
+          <p:nvPr/>
+        </p:nvSpPr>
+        <p:spPr>
+          <a:xfrm>
+            <a:off x="777240" y="960120"/>
+            <a:ext cx="7863840" cy="548640"/>
+          </a:xfrm>
+          <a:prstGeom prst="rect">
+            <a:avLst/>
+          </a:prstGeom>
+          <a:noFill/>
+        </p:spPr>
+        <p:txBody>
+          <a:bodyPr wrap="square" lIns="0" rIns="0" tIns="0" bIns="0" anchor="ctr">
+            <a:spAutoFit/>
+          </a:bodyPr>
+          <a:lstStyle/>
+          <a:p>
+            <a:pPr algn="l"/>
+            <a:r>
+              <a:rPr sz="1400" b="1" i="0">
+                <a:solidFill>
+                  <a:srgbClr val="FFFFFF"/>
+                </a:solidFill>
+                <a:latin typeface="Calibri"/>
+              </a:rPr>
+              <a:t>Reorder + score — same overhead problem</a:t>
+            </a:r>
+          </a:p>
+        </p:txBody>
+      </p:sp>
+      <p:sp>
+        <p:nvSpPr>
+          <p:cNvPr id="8" name="Rectangle 7"/>
+          <p:cNvSpPr/>
+          <p:nvPr/>
+        </p:nvSpPr>
+        <p:spPr>
+          <a:xfrm>
+            <a:off x="8897112" y="960120"/>
+            <a:ext cx="2743200" cy="548640"/>
+          </a:xfrm>
+          <a:prstGeom prst="rect">
+            <a:avLst/>
+          </a:prstGeom>
+          <a:solidFill>
+            <a:srgbClr val="FFFFFF"/>
+          </a:solidFill>
+          <a:ln w="15875">
+            <a:solidFill>
+              <a:srgbClr val="E69F00"/>
+            </a:solidFill>
+          </a:ln>
+          <a:effectLst/>
+        </p:spPr>
+        <p:style>
+          <a:lnRef idx="1">
+            <a:schemeClr val="accent1"/>
+          </a:lnRef>
+          <a:fillRef idx="3">
+            <a:schemeClr val="accent1"/>
+          </a:fillRef>
+          <a:effectRef idx="2">
+            <a:schemeClr val="accent1"/>
+          </a:effectRef>
+          <a:fontRef idx="minor">
+            <a:schemeClr val="lt1"/>
+          </a:fontRef>
+        </p:style>
+        <p:txBody>
+          <a:bodyPr rtlCol="0" anchor="ctr"/>
+          <a:lstStyle/>
+          <a:p>
+            <a:pPr algn="ctr"/>
+          </a:p>
+        </p:txBody>
+      </p:sp>
+      <p:sp>
+        <p:nvSpPr>
+          <p:cNvPr id="9" name="TextBox 8"/>
+          <p:cNvSpPr txBox="1"/>
+          <p:nvPr/>
+        </p:nvSpPr>
+        <p:spPr>
+          <a:xfrm>
+            <a:off x="8988552" y="960120"/>
+            <a:ext cx="2606040" cy="548640"/>
+          </a:xfrm>
+          <a:prstGeom prst="rect">
+            <a:avLst/>
+          </a:prstGeom>
+          <a:noFill/>
+        </p:spPr>
+        <p:txBody>
+          <a:bodyPr wrap="square" lIns="0" rIns="0" tIns="0" bIns="0" anchor="ctr">
+            <a:spAutoFit/>
+          </a:bodyPr>
+          <a:lstStyle/>
+          <a:p>
+            <a:pPr algn="ctr"/>
+            <a:r>
+              <a:rPr sz="1000" b="1" i="0">
+                <a:solidFill>
+                  <a:srgbClr val="E69F00"/>
+                </a:solidFill>
+                <a:latin typeface="Calibri"/>
+              </a:rPr>
+              <a:t>30 trajectories  ·  9 phases</a:t>
+            </a:r>
+          </a:p>
+        </p:txBody>
+      </p:sp>
       <p:pic>
         <p:nvPicPr>
-          <p:cNvPr id="6" name="Picture 5" descr="method_09_llm_reorganizer.png"/>
+          <p:cNvPr id="10" name="Picture 9" descr="method_09_llm_reorganizer.png"/>
           <p:cNvPicPr>
             <a:picLocks noChangeAspect="1"/>
           </p:cNvPicPr>
@@ -4222,7 +4862,7 @@
         </p:blipFill>
         <p:spPr>
           <a:xfrm>
-            <a:off x="548640" y="1522894"/>
+            <a:off x="548640" y="1751494"/>
             <a:ext cx="11091672" cy="4452290"/>
           </a:xfrm>
           <a:prstGeom prst="rect">
@@ -4232,7 +4872,7 @@
       </p:pic>
       <p:sp>
         <p:nvSpPr>
-          <p:cNvPr id="7" name="TextBox 6"/>
+          <p:cNvPr id="11" name="TextBox 10"/>
           <p:cNvSpPr txBox="1"/>
           <p:nvPr/>
         </p:nvSpPr>
@@ -4267,7 +4907,7 @@
       </p:sp>
       <p:sp>
         <p:nvSpPr>
-          <p:cNvPr id="8" name="TextBox 7"/>
+          <p:cNvPr id="12" name="TextBox 11"/>
           <p:cNvSpPr txBox="1"/>
           <p:nvPr/>
         </p:nvSpPr>
@@ -4476,9 +5116,169 @@
           </a:p>
         </p:txBody>
       </p:sp>
+      <p:sp>
+        <p:nvSpPr>
+          <p:cNvPr id="6" name="Rectangle 5"/>
+          <p:cNvSpPr/>
+          <p:nvPr/>
+        </p:nvSpPr>
+        <p:spPr>
+          <a:xfrm>
+            <a:off x="548640" y="960120"/>
+            <a:ext cx="8229600" cy="548640"/>
+          </a:xfrm>
+          <a:prstGeom prst="rect">
+            <a:avLst/>
+          </a:prstGeom>
+          <a:solidFill>
+            <a:srgbClr val="009E73"/>
+          </a:solidFill>
+          <a:ln>
+            <a:noFill/>
+          </a:ln>
+          <a:effectLst/>
+        </p:spPr>
+        <p:style>
+          <a:lnRef idx="1">
+            <a:schemeClr val="accent1"/>
+          </a:lnRef>
+          <a:fillRef idx="3">
+            <a:schemeClr val="accent1"/>
+          </a:fillRef>
+          <a:effectRef idx="2">
+            <a:schemeClr val="accent1"/>
+          </a:effectRef>
+          <a:fontRef idx="minor">
+            <a:schemeClr val="lt1"/>
+          </a:fontRef>
+        </p:style>
+        <p:txBody>
+          <a:bodyPr rtlCol="0" anchor="ctr"/>
+          <a:lstStyle/>
+          <a:p>
+            <a:pPr algn="ctr"/>
+          </a:p>
+        </p:txBody>
+      </p:sp>
+      <p:sp>
+        <p:nvSpPr>
+          <p:cNvPr id="7" name="TextBox 6"/>
+          <p:cNvSpPr txBox="1"/>
+          <p:nvPr/>
+        </p:nvSpPr>
+        <p:spPr>
+          <a:xfrm>
+            <a:off x="777240" y="960120"/>
+            <a:ext cx="7863840" cy="548640"/>
+          </a:xfrm>
+          <a:prstGeom prst="rect">
+            <a:avLst/>
+          </a:prstGeom>
+          <a:noFill/>
+        </p:spPr>
+        <p:txBody>
+          <a:bodyPr wrap="square" lIns="0" rIns="0" tIns="0" bIns="0" anchor="ctr">
+            <a:spAutoFit/>
+          </a:bodyPr>
+          <a:lstStyle/>
+          <a:p>
+            <a:pPr algn="l"/>
+            <a:r>
+              <a:rPr sz="1400" b="1" i="0">
+                <a:solidFill>
+                  <a:srgbClr val="FFFFFF"/>
+                </a:solidFill>
+                <a:latin typeface="Calibri"/>
+              </a:rPr>
+              <a:t>WINS pytest-7490 in 4 edits  ·  ties on retail chain (5/10)</a:t>
+            </a:r>
+          </a:p>
+        </p:txBody>
+      </p:sp>
+      <p:sp>
+        <p:nvSpPr>
+          <p:cNvPr id="8" name="Rectangle 7"/>
+          <p:cNvSpPr/>
+          <p:nvPr/>
+        </p:nvSpPr>
+        <p:spPr>
+          <a:xfrm>
+            <a:off x="8897112" y="960120"/>
+            <a:ext cx="2743200" cy="548640"/>
+          </a:xfrm>
+          <a:prstGeom prst="rect">
+            <a:avLst/>
+          </a:prstGeom>
+          <a:solidFill>
+            <a:srgbClr val="FFFFFF"/>
+          </a:solidFill>
+          <a:ln w="15875">
+            <a:solidFill>
+              <a:srgbClr val="009E73"/>
+            </a:solidFill>
+          </a:ln>
+          <a:effectLst/>
+        </p:spPr>
+        <p:style>
+          <a:lnRef idx="1">
+            <a:schemeClr val="accent1"/>
+          </a:lnRef>
+          <a:fillRef idx="3">
+            <a:schemeClr val="accent1"/>
+          </a:fillRef>
+          <a:effectRef idx="2">
+            <a:schemeClr val="accent1"/>
+          </a:effectRef>
+          <a:fontRef idx="minor">
+            <a:schemeClr val="lt1"/>
+          </a:fontRef>
+        </p:style>
+        <p:txBody>
+          <a:bodyPr rtlCol="0" anchor="ctr"/>
+          <a:lstStyle/>
+          <a:p>
+            <a:pPr algn="ctr"/>
+          </a:p>
+        </p:txBody>
+      </p:sp>
+      <p:sp>
+        <p:nvSpPr>
+          <p:cNvPr id="9" name="TextBox 8"/>
+          <p:cNvSpPr txBox="1"/>
+          <p:nvPr/>
+        </p:nvSpPr>
+        <p:spPr>
+          <a:xfrm>
+            <a:off x="8988552" y="960120"/>
+            <a:ext cx="2606040" cy="548640"/>
+          </a:xfrm>
+          <a:prstGeom prst="rect">
+            <a:avLst/>
+          </a:prstGeom>
+          <a:noFill/>
+        </p:spPr>
+        <p:txBody>
+          <a:bodyPr wrap="square" lIns="0" rIns="0" tIns="0" bIns="0" anchor="ctr">
+            <a:spAutoFit/>
+          </a:bodyPr>
+          <a:lstStyle/>
+          <a:p>
+            <a:pPr algn="ctr"/>
+            <a:r>
+              <a:rPr sz="1000" b="1" i="0">
+                <a:solidFill>
+                  <a:srgbClr val="009E73"/>
+                </a:solidFill>
+                <a:latin typeface="Calibri"/>
+              </a:rPr>
+              <a:t>Phase D 2× + Phase E (10 customers)</a:t>
+            </a:r>
+          </a:p>
+        </p:txBody>
+      </p:sp>
       <p:pic>
         <p:nvPicPr>
-          <p:cNvPr id="6" name="Picture 5" descr="method_10_consumption_evict_plain.png"/>
+          <p:cNvPr id="10" name="Picture 9" descr="method_10_consumption_evict_plain.png"/>
           <p:cNvPicPr>
             <a:picLocks noChangeAspect="1"/>
           </p:cNvPicPr>
@@ -4492,7 +5292,7 @@
         </p:blipFill>
         <p:spPr>
           <a:xfrm>
-            <a:off x="548640" y="1884854"/>
+            <a:off x="548640" y="2113454"/>
             <a:ext cx="11091672" cy="3728371"/>
           </a:xfrm>
           <a:prstGeom prst="rect">
@@ -4502,7 +5302,7 @@
       </p:pic>
       <p:sp>
         <p:nvSpPr>
-          <p:cNvPr id="7" name="TextBox 6"/>
+          <p:cNvPr id="11" name="TextBox 10"/>
           <p:cNvSpPr txBox="1"/>
           <p:nvPr/>
         </p:nvSpPr>
@@ -4537,7 +5337,7 @@
       </p:sp>
       <p:sp>
         <p:nvSpPr>
-          <p:cNvPr id="8" name="TextBox 7"/>
+          <p:cNvPr id="12" name="TextBox 11"/>
           <p:cNvSpPr txBox="1"/>
           <p:nvPr/>
         </p:nvSpPr>
@@ -4746,9 +5546,169 @@
           </a:p>
         </p:txBody>
       </p:sp>
+      <p:sp>
+        <p:nvSpPr>
+          <p:cNvPr id="6" name="Rectangle 5"/>
+          <p:cNvSpPr/>
+          <p:nvPr/>
+        </p:nvSpPr>
+        <p:spPr>
+          <a:xfrm>
+            <a:off x="548640" y="960120"/>
+            <a:ext cx="8229600" cy="548640"/>
+          </a:xfrm>
+          <a:prstGeom prst="rect">
+            <a:avLst/>
+          </a:prstGeom>
+          <a:solidFill>
+            <a:srgbClr val="E69F00"/>
+          </a:solidFill>
+          <a:ln>
+            <a:noFill/>
+          </a:ln>
+          <a:effectLst/>
+        </p:spPr>
+        <p:style>
+          <a:lnRef idx="1">
+            <a:schemeClr val="accent1"/>
+          </a:lnRef>
+          <a:fillRef idx="3">
+            <a:schemeClr val="accent1"/>
+          </a:fillRef>
+          <a:effectRef idx="2">
+            <a:schemeClr val="accent1"/>
+          </a:effectRef>
+          <a:fontRef idx="minor">
+            <a:schemeClr val="lt1"/>
+          </a:fontRef>
+        </p:style>
+        <p:txBody>
+          <a:bodyPr rtlCol="0" anchor="ctr"/>
+          <a:lstStyle/>
+          <a:p>
+            <a:pPr algn="ctr"/>
+          </a:p>
+        </p:txBody>
+      </p:sp>
+      <p:sp>
+        <p:nvSpPr>
+          <p:cNvPr id="7" name="TextBox 6"/>
+          <p:cNvSpPr txBox="1"/>
+          <p:nvPr/>
+        </p:nvSpPr>
+        <p:spPr>
+          <a:xfrm>
+            <a:off x="777240" y="960120"/>
+            <a:ext cx="7863840" cy="548640"/>
+          </a:xfrm>
+          <a:prstGeom prst="rect">
+            <a:avLst/>
+          </a:prstGeom>
+          <a:noFill/>
+        </p:spPr>
+        <p:txBody>
+          <a:bodyPr wrap="square" lIns="0" rIns="0" tIns="0" bIns="0" anchor="ctr">
+            <a:spAutoFit/>
+          </a:bodyPr>
+          <a:lstStyle/>
+          <a:p>
+            <a:pPr algn="l"/>
+            <a:r>
+              <a:rPr sz="1400" b="1" i="0">
+                <a:solidFill>
+                  <a:srgbClr val="FFFFFF"/>
+                </a:solidFill>
+                <a:latin typeface="Calibri"/>
+              </a:rPr>
+              <a:t>LOSES pytest-7490 — 18 edits, 0/2 success (mechanism finding)</a:t>
+            </a:r>
+          </a:p>
+        </p:txBody>
+      </p:sp>
+      <p:sp>
+        <p:nvSpPr>
+          <p:cNvPr id="8" name="Rectangle 7"/>
+          <p:cNvSpPr/>
+          <p:nvPr/>
+        </p:nvSpPr>
+        <p:spPr>
+          <a:xfrm>
+            <a:off x="8897112" y="960120"/>
+            <a:ext cx="2743200" cy="548640"/>
+          </a:xfrm>
+          <a:prstGeom prst="rect">
+            <a:avLst/>
+          </a:prstGeom>
+          <a:solidFill>
+            <a:srgbClr val="FFFFFF"/>
+          </a:solidFill>
+          <a:ln w="15875">
+            <a:solidFill>
+              <a:srgbClr val="E69F00"/>
+            </a:solidFill>
+          </a:ln>
+          <a:effectLst/>
+        </p:spPr>
+        <p:style>
+          <a:lnRef idx="1">
+            <a:schemeClr val="accent1"/>
+          </a:lnRef>
+          <a:fillRef idx="3">
+            <a:schemeClr val="accent1"/>
+          </a:fillRef>
+          <a:effectRef idx="2">
+            <a:schemeClr val="accent1"/>
+          </a:effectRef>
+          <a:fontRef idx="minor">
+            <a:schemeClr val="lt1"/>
+          </a:fontRef>
+        </p:style>
+        <p:txBody>
+          <a:bodyPr rtlCol="0" anchor="ctr"/>
+          <a:lstStyle/>
+          <a:p>
+            <a:pPr algn="ctr"/>
+          </a:p>
+        </p:txBody>
+      </p:sp>
+      <p:sp>
+        <p:nvSpPr>
+          <p:cNvPr id="9" name="TextBox 8"/>
+          <p:cNvSpPr txBox="1"/>
+          <p:nvPr/>
+        </p:nvSpPr>
+        <p:spPr>
+          <a:xfrm>
+            <a:off x="8988552" y="960120"/>
+            <a:ext cx="2606040" cy="548640"/>
+          </a:xfrm>
+          <a:prstGeom prst="rect">
+            <a:avLst/>
+          </a:prstGeom>
+          <a:noFill/>
+        </p:spPr>
+        <p:txBody>
+          <a:bodyPr wrap="square" lIns="0" rIns="0" tIns="0" bIns="0" anchor="ctr">
+            <a:spAutoFit/>
+          </a:bodyPr>
+          <a:lstStyle/>
+          <a:p>
+            <a:pPr algn="ctr"/>
+            <a:r>
+              <a:rPr sz="1000" b="1" i="0">
+                <a:solidFill>
+                  <a:srgbClr val="E69F00"/>
+                </a:solidFill>
+                <a:latin typeface="Calibri"/>
+              </a:rPr>
+              <a:t>Phase D 2×</a:t>
+            </a:r>
+          </a:p>
+        </p:txBody>
+      </p:sp>
       <p:pic>
         <p:nvPicPr>
-          <p:cNvPr id="6" name="Picture 5" descr="method_11_consumption_evict_facts.png"/>
+          <p:cNvPr id="10" name="Picture 9" descr="method_11_consumption_evict_facts.png"/>
           <p:cNvPicPr>
             <a:picLocks noChangeAspect="1"/>
           </p:cNvPicPr>
@@ -4762,7 +5722,7 @@
         </p:blipFill>
         <p:spPr>
           <a:xfrm>
-            <a:off x="548640" y="1744702"/>
+            <a:off x="548640" y="1973302"/>
             <a:ext cx="11091672" cy="4008674"/>
           </a:xfrm>
           <a:prstGeom prst="rect">
@@ -4772,7 +5732,7 @@
       </p:pic>
       <p:sp>
         <p:nvSpPr>
-          <p:cNvPr id="7" name="TextBox 6"/>
+          <p:cNvPr id="11" name="TextBox 10"/>
           <p:cNvSpPr txBox="1"/>
           <p:nvPr/>
         </p:nvSpPr>
@@ -4807,7 +5767,7 @@
       </p:sp>
       <p:sp>
         <p:nvSpPr>
-          <p:cNvPr id="8" name="TextBox 7"/>
+          <p:cNvPr id="12" name="TextBox 11"/>
           <p:cNvSpPr txBox="1"/>
           <p:nvPr/>
         </p:nvSpPr>
@@ -5016,9 +5976,169 @@
           </a:p>
         </p:txBody>
       </p:sp>
+      <p:sp>
+        <p:nvSpPr>
+          <p:cNvPr id="6" name="Rectangle 5"/>
+          <p:cNvSpPr/>
+          <p:nvPr/>
+        </p:nvSpPr>
+        <p:spPr>
+          <a:xfrm>
+            <a:off x="548640" y="960120"/>
+            <a:ext cx="8229600" cy="548640"/>
+          </a:xfrm>
+          <a:prstGeom prst="rect">
+            <a:avLst/>
+          </a:prstGeom>
+          <a:solidFill>
+            <a:srgbClr val="009E73"/>
+          </a:solidFill>
+          <a:ln>
+            <a:noFill/>
+          </a:ln>
+          <a:effectLst/>
+        </p:spPr>
+        <p:style>
+          <a:lnRef idx="1">
+            <a:schemeClr val="accent1"/>
+          </a:lnRef>
+          <a:fillRef idx="3">
+            <a:schemeClr val="accent1"/>
+          </a:fillRef>
+          <a:effectRef idx="2">
+            <a:schemeClr val="accent1"/>
+          </a:effectRef>
+          <a:fontRef idx="minor">
+            <a:schemeClr val="lt1"/>
+          </a:fontRef>
+        </p:style>
+        <p:txBody>
+          <a:bodyPr rtlCol="0" anchor="ctr"/>
+          <a:lstStyle/>
+          <a:p>
+            <a:pPr algn="ctr"/>
+          </a:p>
+        </p:txBody>
+      </p:sp>
+      <p:sp>
+        <p:nvSpPr>
+          <p:cNvPr id="7" name="TextBox 6"/>
+          <p:cNvSpPr txBox="1"/>
+          <p:nvPr/>
+        </p:nvSpPr>
+        <p:spPr>
+          <a:xfrm>
+            <a:off x="777240" y="960120"/>
+            <a:ext cx="7863840" cy="548640"/>
+          </a:xfrm>
+          <a:prstGeom prst="rect">
+            <a:avLst/>
+          </a:prstGeom>
+          <a:noFill/>
+        </p:spPr>
+        <p:txBody>
+          <a:bodyPr wrap="square" lIns="0" rIns="0" tIns="0" bIns="0" anchor="ctr">
+            <a:spAutoFit/>
+          </a:bodyPr>
+          <a:lstStyle/>
+          <a:p>
+            <a:pPr algn="l"/>
+            <a:r>
+              <a:rPr sz="1400" b="1" i="0">
+                <a:solidFill>
+                  <a:srgbClr val="FFFFFF"/>
+                </a:solidFill>
+                <a:latin typeface="Calibri"/>
+              </a:rPr>
+              <a:t>Ties plain on retail chain (5/10) — cleanest design point</a:t>
+            </a:r>
+          </a:p>
+        </p:txBody>
+      </p:sp>
+      <p:sp>
+        <p:nvSpPr>
+          <p:cNvPr id="8" name="Rectangle 7"/>
+          <p:cNvSpPr/>
+          <p:nvPr/>
+        </p:nvSpPr>
+        <p:spPr>
+          <a:xfrm>
+            <a:off x="8897112" y="960120"/>
+            <a:ext cx="2743200" cy="548640"/>
+          </a:xfrm>
+          <a:prstGeom prst="rect">
+            <a:avLst/>
+          </a:prstGeom>
+          <a:solidFill>
+            <a:srgbClr val="FFFFFF"/>
+          </a:solidFill>
+          <a:ln w="15875">
+            <a:solidFill>
+              <a:srgbClr val="009E73"/>
+            </a:solidFill>
+          </a:ln>
+          <a:effectLst/>
+        </p:spPr>
+        <p:style>
+          <a:lnRef idx="1">
+            <a:schemeClr val="accent1"/>
+          </a:lnRef>
+          <a:fillRef idx="3">
+            <a:schemeClr val="accent1"/>
+          </a:fillRef>
+          <a:effectRef idx="2">
+            <a:schemeClr val="accent1"/>
+          </a:effectRef>
+          <a:fontRef idx="minor">
+            <a:schemeClr val="lt1"/>
+          </a:fontRef>
+        </p:style>
+        <p:txBody>
+          <a:bodyPr rtlCol="0" anchor="ctr"/>
+          <a:lstStyle/>
+          <a:p>
+            <a:pPr algn="ctr"/>
+          </a:p>
+        </p:txBody>
+      </p:sp>
+      <p:sp>
+        <p:nvSpPr>
+          <p:cNvPr id="9" name="TextBox 8"/>
+          <p:cNvSpPr txBox="1"/>
+          <p:nvPr/>
+        </p:nvSpPr>
+        <p:spPr>
+          <a:xfrm>
+            <a:off x="8988552" y="960120"/>
+            <a:ext cx="2606040" cy="548640"/>
+          </a:xfrm>
+          <a:prstGeom prst="rect">
+            <a:avLst/>
+          </a:prstGeom>
+          <a:noFill/>
+        </p:spPr>
+        <p:txBody>
+          <a:bodyPr wrap="square" lIns="0" rIns="0" tIns="0" bIns="0" anchor="ctr">
+            <a:spAutoFit/>
+          </a:bodyPr>
+          <a:lstStyle/>
+          <a:p>
+            <a:pPr algn="ctr"/>
+            <a:r>
+              <a:rPr sz="1000" b="1" i="0">
+                <a:solidFill>
+                  <a:srgbClr val="009E73"/>
+                </a:solidFill>
+                <a:latin typeface="Calibri"/>
+              </a:rPr>
+              <a:t>Phase E (10 customers)</a:t>
+            </a:r>
+          </a:p>
+        </p:txBody>
+      </p:sp>
       <p:pic>
         <p:nvPicPr>
-          <p:cNvPr id="6" name="Picture 5" descr="method_12_consumption_evict_outline.png"/>
+          <p:cNvPr id="10" name="Picture 9" descr="method_12_consumption_evict_outline.png"/>
           <p:cNvPicPr>
             <a:picLocks noChangeAspect="1"/>
           </p:cNvPicPr>
@@ -5032,7 +6152,7 @@
         </p:blipFill>
         <p:spPr>
           <a:xfrm>
-            <a:off x="548640" y="1522894"/>
+            <a:off x="548640" y="1751494"/>
             <a:ext cx="11091672" cy="4452290"/>
           </a:xfrm>
           <a:prstGeom prst="rect">
@@ -5042,7 +6162,7 @@
       </p:pic>
       <p:sp>
         <p:nvSpPr>
-          <p:cNvPr id="7" name="TextBox 6"/>
+          <p:cNvPr id="11" name="TextBox 10"/>
           <p:cNvSpPr txBox="1"/>
           <p:nvPr/>
         </p:nvSpPr>
@@ -5077,7 +6197,7 @@
       </p:sp>
       <p:sp>
         <p:nvSpPr>
-          <p:cNvPr id="8" name="TextBox 7"/>
+          <p:cNvPr id="12" name="TextBox 11"/>
           <p:cNvSpPr txBox="1"/>
           <p:nvPr/>
         </p:nvSpPr>
@@ -6642,9 +7762,169 @@
           </a:p>
         </p:txBody>
       </p:sp>
+      <p:sp>
+        <p:nvSpPr>
+          <p:cNvPr id="6" name="Rectangle 5"/>
+          <p:cNvSpPr/>
+          <p:nvPr/>
+        </p:nvSpPr>
+        <p:spPr>
+          <a:xfrm>
+            <a:off x="548640" y="960120"/>
+            <a:ext cx="8229600" cy="548640"/>
+          </a:xfrm>
+          <a:prstGeom prst="rect">
+            <a:avLst/>
+          </a:prstGeom>
+          <a:solidFill>
+            <a:srgbClr val="1E3A8A"/>
+          </a:solidFill>
+          <a:ln>
+            <a:noFill/>
+          </a:ln>
+          <a:effectLst/>
+        </p:spPr>
+        <p:style>
+          <a:lnRef idx="1">
+            <a:schemeClr val="accent1"/>
+          </a:lnRef>
+          <a:fillRef idx="3">
+            <a:schemeClr val="accent1"/>
+          </a:fillRef>
+          <a:effectRef idx="2">
+            <a:schemeClr val="accent1"/>
+          </a:effectRef>
+          <a:fontRef idx="minor">
+            <a:schemeClr val="lt1"/>
+          </a:fontRef>
+        </p:style>
+        <p:txBody>
+          <a:bodyPr rtlCol="0" anchor="ctr"/>
+          <a:lstStyle/>
+          <a:p>
+            <a:pPr algn="ctr"/>
+          </a:p>
+        </p:txBody>
+      </p:sp>
+      <p:sp>
+        <p:nvSpPr>
+          <p:cNvPr id="7" name="TextBox 6"/>
+          <p:cNvSpPr txBox="1"/>
+          <p:nvPr/>
+        </p:nvSpPr>
+        <p:spPr>
+          <a:xfrm>
+            <a:off x="777240" y="960120"/>
+            <a:ext cx="7863840" cy="548640"/>
+          </a:xfrm>
+          <a:prstGeom prst="rect">
+            <a:avLst/>
+          </a:prstGeom>
+          <a:noFill/>
+        </p:spPr>
+        <p:txBody>
+          <a:bodyPr wrap="square" lIns="0" rIns="0" tIns="0" bIns="0" anchor="ctr">
+            <a:spAutoFit/>
+          </a:bodyPr>
+          <a:lstStyle/>
+          <a:p>
+            <a:pPr algn="l"/>
+            <a:r>
+              <a:rPr sz="1400" b="1" i="0">
+                <a:solidFill>
+                  <a:srgbClr val="FFFFFF"/>
+                </a:solidFill>
+                <a:latin typeface="Calibri"/>
+              </a:rPr>
+              <a:t>Pareto-dominates on N=10 SWE-bench Lite (Haiku 4.5)</a:t>
+            </a:r>
+          </a:p>
+        </p:txBody>
+      </p:sp>
+      <p:sp>
+        <p:nvSpPr>
+          <p:cNvPr id="8" name="Rectangle 7"/>
+          <p:cNvSpPr/>
+          <p:nvPr/>
+        </p:nvSpPr>
+        <p:spPr>
+          <a:xfrm>
+            <a:off x="8897112" y="960120"/>
+            <a:ext cx="2743200" cy="548640"/>
+          </a:xfrm>
+          <a:prstGeom prst="rect">
+            <a:avLst/>
+          </a:prstGeom>
+          <a:solidFill>
+            <a:srgbClr val="FFFFFF"/>
+          </a:solidFill>
+          <a:ln w="15875">
+            <a:solidFill>
+              <a:srgbClr val="1E3A8A"/>
+            </a:solidFill>
+          </a:ln>
+          <a:effectLst/>
+        </p:spPr>
+        <p:style>
+          <a:lnRef idx="1">
+            <a:schemeClr val="accent1"/>
+          </a:lnRef>
+          <a:fillRef idx="3">
+            <a:schemeClr val="accent1"/>
+          </a:fillRef>
+          <a:effectRef idx="2">
+            <a:schemeClr val="accent1"/>
+          </a:effectRef>
+          <a:fontRef idx="minor">
+            <a:schemeClr val="lt1"/>
+          </a:fontRef>
+        </p:style>
+        <p:txBody>
+          <a:bodyPr rtlCol="0" anchor="ctr"/>
+          <a:lstStyle/>
+          <a:p>
+            <a:pPr algn="ctr"/>
+          </a:p>
+        </p:txBody>
+      </p:sp>
+      <p:sp>
+        <p:nvSpPr>
+          <p:cNvPr id="9" name="TextBox 8"/>
+          <p:cNvSpPr txBox="1"/>
+          <p:nvPr/>
+        </p:nvSpPr>
+        <p:spPr>
+          <a:xfrm>
+            <a:off x="8988552" y="960120"/>
+            <a:ext cx="2606040" cy="548640"/>
+          </a:xfrm>
+          <a:prstGeom prst="rect">
+            <a:avLst/>
+          </a:prstGeom>
+          <a:noFill/>
+        </p:spPr>
+        <p:txBody>
+          <a:bodyPr wrap="square" lIns="0" rIns="0" tIns="0" bIns="0" anchor="ctr">
+            <a:spAutoFit/>
+          </a:bodyPr>
+          <a:lstStyle/>
+          <a:p>
+            <a:pPr algn="ctr"/>
+            <a:r>
+              <a:rPr sz="1000" b="1" i="0">
+                <a:solidFill>
+                  <a:srgbClr val="1E3A8A"/>
+                </a:solidFill>
+                <a:latin typeface="Calibri"/>
+              </a:rPr>
+              <a:t>84+ trajectories  ·  20 phases</a:t>
+            </a:r>
+          </a:p>
+        </p:txBody>
+      </p:sp>
       <p:pic>
         <p:nvPicPr>
-          <p:cNvPr id="6" name="Picture 5" descr="method_01_none.png"/>
+          <p:cNvPr id="10" name="Picture 9" descr="method_01_none.png"/>
           <p:cNvPicPr>
             <a:picLocks noChangeAspect="1"/>
           </p:cNvPicPr>
@@ -6658,7 +7938,7 @@
         </p:blipFill>
         <p:spPr>
           <a:xfrm>
-            <a:off x="548640" y="1860995"/>
+            <a:off x="548640" y="2089595"/>
             <a:ext cx="11091672" cy="3776089"/>
           </a:xfrm>
           <a:prstGeom prst="rect">
@@ -6668,7 +7948,7 @@
       </p:pic>
       <p:sp>
         <p:nvSpPr>
-          <p:cNvPr id="7" name="TextBox 6"/>
+          <p:cNvPr id="11" name="TextBox 10"/>
           <p:cNvSpPr txBox="1"/>
           <p:nvPr/>
         </p:nvSpPr>
@@ -6703,7 +7983,7 @@
       </p:sp>
       <p:sp>
         <p:nvSpPr>
-          <p:cNvPr id="8" name="TextBox 7"/>
+          <p:cNvPr id="12" name="TextBox 11"/>
           <p:cNvSpPr txBox="1"/>
           <p:nvPr/>
         </p:nvSpPr>
@@ -6912,9 +8192,169 @@
           </a:p>
         </p:txBody>
       </p:sp>
+      <p:sp>
+        <p:nvSpPr>
+          <p:cNvPr id="6" name="Rectangle 5"/>
+          <p:cNvSpPr/>
+          <p:nvPr/>
+        </p:nvSpPr>
+        <p:spPr>
+          <a:xfrm>
+            <a:off x="548640" y="960120"/>
+            <a:ext cx="8229600" cy="548640"/>
+          </a:xfrm>
+          <a:prstGeom prst="rect">
+            <a:avLst/>
+          </a:prstGeom>
+          <a:solidFill>
+            <a:srgbClr val="E69F00"/>
+          </a:solidFill>
+          <a:ln>
+            <a:noFill/>
+          </a:ln>
+          <a:effectLst/>
+        </p:spPr>
+        <p:style>
+          <a:lnRef idx="1">
+            <a:schemeClr val="accent1"/>
+          </a:lnRef>
+          <a:fillRef idx="3">
+            <a:schemeClr val="accent1"/>
+          </a:fillRef>
+          <a:effectRef idx="2">
+            <a:schemeClr val="accent1"/>
+          </a:effectRef>
+          <a:fontRef idx="minor">
+            <a:schemeClr val="lt1"/>
+          </a:fontRef>
+        </p:style>
+        <p:txBody>
+          <a:bodyPr rtlCol="0" anchor="ctr"/>
+          <a:lstStyle/>
+          <a:p>
+            <a:pPr algn="ctr"/>
+          </a:p>
+        </p:txBody>
+      </p:sp>
+      <p:sp>
+        <p:nvSpPr>
+          <p:cNvPr id="7" name="TextBox 6"/>
+          <p:cNvSpPr txBox="1"/>
+          <p:nvPr/>
+        </p:nvSpPr>
+        <p:spPr>
+          <a:xfrm>
+            <a:off x="777240" y="960120"/>
+            <a:ext cx="7863840" cy="548640"/>
+          </a:xfrm>
+          <a:prstGeom prst="rect">
+            <a:avLst/>
+          </a:prstGeom>
+          <a:noFill/>
+        </p:spPr>
+        <p:txBody>
+          <a:bodyPr wrap="square" lIns="0" rIns="0" tIns="0" bIns="0" anchor="ctr">
+            <a:spAutoFit/>
+          </a:bodyPr>
+          <a:lstStyle/>
+          <a:p>
+            <a:pPr algn="l"/>
+            <a:r>
+              <a:rPr sz="1400" b="1" i="0">
+                <a:solidFill>
+                  <a:srgbClr val="FFFFFF"/>
+                </a:solidFill>
+                <a:latin typeface="Calibri"/>
+              </a:rPr>
+              <a:t>Always loses on cost — every fire writes uncached tokens</a:t>
+            </a:r>
+          </a:p>
+        </p:txBody>
+      </p:sp>
+      <p:sp>
+        <p:nvSpPr>
+          <p:cNvPr id="8" name="Rectangle 7"/>
+          <p:cNvSpPr/>
+          <p:nvPr/>
+        </p:nvSpPr>
+        <p:spPr>
+          <a:xfrm>
+            <a:off x="8897112" y="960120"/>
+            <a:ext cx="2743200" cy="548640"/>
+          </a:xfrm>
+          <a:prstGeom prst="rect">
+            <a:avLst/>
+          </a:prstGeom>
+          <a:solidFill>
+            <a:srgbClr val="FFFFFF"/>
+          </a:solidFill>
+          <a:ln w="15875">
+            <a:solidFill>
+              <a:srgbClr val="E69F00"/>
+            </a:solidFill>
+          </a:ln>
+          <a:effectLst/>
+        </p:spPr>
+        <p:style>
+          <a:lnRef idx="1">
+            <a:schemeClr val="accent1"/>
+          </a:lnRef>
+          <a:fillRef idx="3">
+            <a:schemeClr val="accent1"/>
+          </a:fillRef>
+          <a:effectRef idx="2">
+            <a:schemeClr val="accent1"/>
+          </a:effectRef>
+          <a:fontRef idx="minor">
+            <a:schemeClr val="lt1"/>
+          </a:fontRef>
+        </p:style>
+        <p:txBody>
+          <a:bodyPr rtlCol="0" anchor="ctr"/>
+          <a:lstStyle/>
+          <a:p>
+            <a:pPr algn="ctr"/>
+          </a:p>
+        </p:txBody>
+      </p:sp>
+      <p:sp>
+        <p:nvSpPr>
+          <p:cNvPr id="9" name="TextBox 8"/>
+          <p:cNvSpPr txBox="1"/>
+          <p:nvPr/>
+        </p:nvSpPr>
+        <p:spPr>
+          <a:xfrm>
+            <a:off x="8988552" y="960120"/>
+            <a:ext cx="2606040" cy="548640"/>
+          </a:xfrm>
+          <a:prstGeom prst="rect">
+            <a:avLst/>
+          </a:prstGeom>
+          <a:noFill/>
+        </p:spPr>
+        <p:txBody>
+          <a:bodyPr wrap="square" lIns="0" rIns="0" tIns="0" bIns="0" anchor="ctr">
+            <a:spAutoFit/>
+          </a:bodyPr>
+          <a:lstStyle/>
+          <a:p>
+            <a:pPr algn="ctr"/>
+            <a:r>
+              <a:rPr sz="1000" b="1" i="0">
+                <a:solidFill>
+                  <a:srgbClr val="E69F00"/>
+                </a:solidFill>
+                <a:latin typeface="Calibri"/>
+              </a:rPr>
+              <a:t>tested on τ-bench airline + SWE-bench Lite</a:t>
+            </a:r>
+          </a:p>
+        </p:txBody>
+      </p:sp>
       <p:pic>
         <p:nvPicPr>
-          <p:cNvPr id="6" name="Picture 5" descr="method_02_naive_summary.png"/>
+          <p:cNvPr id="10" name="Picture 9" descr="method_02_naive_summary.png"/>
           <p:cNvPicPr>
             <a:picLocks noChangeAspect="1"/>
           </p:cNvPicPr>
@@ -6928,7 +8368,7 @@
         </p:blipFill>
         <p:spPr>
           <a:xfrm>
-            <a:off x="548640" y="1522894"/>
+            <a:off x="548640" y="1751494"/>
             <a:ext cx="11091672" cy="4452290"/>
           </a:xfrm>
           <a:prstGeom prst="rect">
@@ -6938,7 +8378,7 @@
       </p:pic>
       <p:sp>
         <p:nvSpPr>
-          <p:cNvPr id="7" name="TextBox 6"/>
+          <p:cNvPr id="11" name="TextBox 10"/>
           <p:cNvSpPr txBox="1"/>
           <p:nvPr/>
         </p:nvSpPr>
@@ -6973,7 +8413,7 @@
       </p:sp>
       <p:sp>
         <p:nvSpPr>
-          <p:cNvPr id="8" name="TextBox 7"/>
+          <p:cNvPr id="12" name="TextBox 11"/>
           <p:cNvSpPr txBox="1"/>
           <p:nvPr/>
         </p:nvSpPr>
@@ -7182,9 +8622,169 @@
           </a:p>
         </p:txBody>
       </p:sp>
+      <p:sp>
+        <p:nvSpPr>
+          <p:cNvPr id="6" name="Rectangle 5"/>
+          <p:cNvSpPr/>
+          <p:nvPr/>
+        </p:nvSpPr>
+        <p:spPr>
+          <a:xfrm>
+            <a:off x="548640" y="960120"/>
+            <a:ext cx="8229600" cy="548640"/>
+          </a:xfrm>
+          <a:prstGeom prst="rect">
+            <a:avLst/>
+          </a:prstGeom>
+          <a:solidFill>
+            <a:srgbClr val="1E3A8A"/>
+          </a:solidFill>
+          <a:ln>
+            <a:noFill/>
+          </a:ln>
+          <a:effectLst/>
+        </p:spPr>
+        <p:style>
+          <a:lnRef idx="1">
+            <a:schemeClr val="accent1"/>
+          </a:lnRef>
+          <a:fillRef idx="3">
+            <a:schemeClr val="accent1"/>
+          </a:fillRef>
+          <a:effectRef idx="2">
+            <a:schemeClr val="accent1"/>
+          </a:effectRef>
+          <a:fontRef idx="minor">
+            <a:schemeClr val="lt1"/>
+          </a:fontRef>
+        </p:style>
+        <p:txBody>
+          <a:bodyPr rtlCol="0" anchor="ctr"/>
+          <a:lstStyle/>
+          <a:p>
+            <a:pPr algn="ctr"/>
+          </a:p>
+        </p:txBody>
+      </p:sp>
+      <p:sp>
+        <p:nvSpPr>
+          <p:cNvPr id="7" name="TextBox 6"/>
+          <p:cNvSpPr txBox="1"/>
+          <p:nvPr/>
+        </p:nvSpPr>
+        <p:spPr>
+          <a:xfrm>
+            <a:off x="777240" y="960120"/>
+            <a:ext cx="7863840" cy="548640"/>
+          </a:xfrm>
+          <a:prstGeom prst="rect">
+            <a:avLst/>
+          </a:prstGeom>
+          <a:noFill/>
+        </p:spPr>
+        <p:txBody>
+          <a:bodyPr wrap="square" lIns="0" rIns="0" tIns="0" bIns="0" anchor="ctr">
+            <a:spAutoFit/>
+          </a:bodyPr>
+          <a:lstStyle/>
+          <a:p>
+            <a:pPr algn="l"/>
+            <a:r>
+              <a:rPr sz="1400" b="1" i="0">
+                <a:solidFill>
+                  <a:srgbClr val="FFFFFF"/>
+                </a:solidFill>
+                <a:latin typeface="Calibri"/>
+              </a:rPr>
+              <a:t>Rarely fires — needs an outlier-large observation</a:t>
+            </a:r>
+          </a:p>
+        </p:txBody>
+      </p:sp>
+      <p:sp>
+        <p:nvSpPr>
+          <p:cNvPr id="8" name="Rectangle 7"/>
+          <p:cNvSpPr/>
+          <p:nvPr/>
+        </p:nvSpPr>
+        <p:spPr>
+          <a:xfrm>
+            <a:off x="8897112" y="960120"/>
+            <a:ext cx="2743200" cy="548640"/>
+          </a:xfrm>
+          <a:prstGeom prst="rect">
+            <a:avLst/>
+          </a:prstGeom>
+          <a:solidFill>
+            <a:srgbClr val="FFFFFF"/>
+          </a:solidFill>
+          <a:ln w="15875">
+            <a:solidFill>
+              <a:srgbClr val="1E3A8A"/>
+            </a:solidFill>
+          </a:ln>
+          <a:effectLst/>
+        </p:spPr>
+        <p:style>
+          <a:lnRef idx="1">
+            <a:schemeClr val="accent1"/>
+          </a:lnRef>
+          <a:fillRef idx="3">
+            <a:schemeClr val="accent1"/>
+          </a:fillRef>
+          <a:effectRef idx="2">
+            <a:schemeClr val="accent1"/>
+          </a:effectRef>
+          <a:fontRef idx="minor">
+            <a:schemeClr val="lt1"/>
+          </a:fontRef>
+        </p:style>
+        <p:txBody>
+          <a:bodyPr rtlCol="0" anchor="ctr"/>
+          <a:lstStyle/>
+          <a:p>
+            <a:pPr algn="ctr"/>
+          </a:p>
+        </p:txBody>
+      </p:sp>
+      <p:sp>
+        <p:nvSpPr>
+          <p:cNvPr id="9" name="TextBox 8"/>
+          <p:cNvSpPr txBox="1"/>
+          <p:nvPr/>
+        </p:nvSpPr>
+        <p:spPr>
+          <a:xfrm>
+            <a:off x="8988552" y="960120"/>
+            <a:ext cx="2606040" cy="548640"/>
+          </a:xfrm>
+          <a:prstGeom prst="rect">
+            <a:avLst/>
+          </a:prstGeom>
+          <a:noFill/>
+        </p:spPr>
+        <p:txBody>
+          <a:bodyPr wrap="square" lIns="0" rIns="0" tIns="0" bIns="0" anchor="ctr">
+            <a:spAutoFit/>
+          </a:bodyPr>
+          <a:lstStyle/>
+          <a:p>
+            <a:pPr algn="ctr"/>
+            <a:r>
+              <a:rPr sz="1000" b="1" i="0">
+                <a:solidFill>
+                  <a:srgbClr val="1E3A8A"/>
+                </a:solidFill>
+                <a:latin typeface="Calibri"/>
+              </a:rPr>
+              <a:t>10 trajectories  ·  Phase B + C</a:t>
+            </a:r>
+          </a:p>
+        </p:txBody>
+      </p:sp>
       <p:pic>
         <p:nvPicPr>
-          <p:cNvPr id="6" name="Picture 5" descr="method_03_microcompact.png"/>
+          <p:cNvPr id="10" name="Picture 9" descr="method_03_microcompact.png"/>
           <p:cNvPicPr>
             <a:picLocks noChangeAspect="1"/>
           </p:cNvPicPr>
@@ -7198,7 +8798,7 @@
         </p:blipFill>
         <p:spPr>
           <a:xfrm>
-            <a:off x="548640" y="1522894"/>
+            <a:off x="548640" y="1751494"/>
             <a:ext cx="11091672" cy="4452290"/>
           </a:xfrm>
           <a:prstGeom prst="rect">
@@ -7208,7 +8808,7 @@
       </p:pic>
       <p:sp>
         <p:nvSpPr>
-          <p:cNvPr id="7" name="TextBox 6"/>
+          <p:cNvPr id="11" name="TextBox 10"/>
           <p:cNvSpPr txBox="1"/>
           <p:nvPr/>
         </p:nvSpPr>
@@ -7243,7 +8843,7 @@
       </p:sp>
       <p:sp>
         <p:nvSpPr>
-          <p:cNvPr id="8" name="TextBox 7"/>
+          <p:cNvPr id="12" name="TextBox 11"/>
           <p:cNvSpPr txBox="1"/>
           <p:nvPr/>
         </p:nvSpPr>
@@ -7452,9 +9052,169 @@
           </a:p>
         </p:txBody>
       </p:sp>
+      <p:sp>
+        <p:nvSpPr>
+          <p:cNvPr id="6" name="Rectangle 5"/>
+          <p:cNvSpPr/>
+          <p:nvPr/>
+        </p:nvSpPr>
+        <p:spPr>
+          <a:xfrm>
+            <a:off x="548640" y="960120"/>
+            <a:ext cx="8229600" cy="548640"/>
+          </a:xfrm>
+          <a:prstGeom prst="rect">
+            <a:avLst/>
+          </a:prstGeom>
+          <a:solidFill>
+            <a:srgbClr val="E69F00"/>
+          </a:solidFill>
+          <a:ln>
+            <a:noFill/>
+          </a:ln>
+          <a:effectLst/>
+        </p:spPr>
+        <p:style>
+          <a:lnRef idx="1">
+            <a:schemeClr val="accent1"/>
+          </a:lnRef>
+          <a:fillRef idx="3">
+            <a:schemeClr val="accent1"/>
+          </a:fillRef>
+          <a:effectRef idx="2">
+            <a:schemeClr val="accent1"/>
+          </a:effectRef>
+          <a:fontRef idx="minor">
+            <a:schemeClr val="lt1"/>
+          </a:fontRef>
+        </p:style>
+        <p:txBody>
+          <a:bodyPr rtlCol="0" anchor="ctr"/>
+          <a:lstStyle/>
+          <a:p>
+            <a:pPr algn="ctr"/>
+          </a:p>
+        </p:txBody>
+      </p:sp>
+      <p:sp>
+        <p:nvSpPr>
+          <p:cNvPr id="7" name="TextBox 6"/>
+          <p:cNvSpPr txBox="1"/>
+          <p:nvPr/>
+        </p:nvSpPr>
+        <p:spPr>
+          <a:xfrm>
+            <a:off x="777240" y="960120"/>
+            <a:ext cx="7863840" cy="548640"/>
+          </a:xfrm>
+          <a:prstGeom prst="rect">
+            <a:avLst/>
+          </a:prstGeom>
+          <a:noFill/>
+        </p:spPr>
+        <p:txBody>
+          <a:bodyPr wrap="square" lIns="0" rIns="0" tIns="0" bIns="0" anchor="ctr">
+            <a:spAutoFit/>
+          </a:bodyPr>
+          <a:lstStyle/>
+          <a:p>
+            <a:pPr algn="l"/>
+            <a:r>
+              <a:rPr sz="1400" b="1" i="0">
+                <a:solidFill>
+                  <a:srgbClr val="FFFFFF"/>
+                </a:solidFill>
+                <a:latin typeface="Calibri"/>
+              </a:rPr>
+              <a:t>Stable cliff cost; loses ~30% on cost vs none</a:t>
+            </a:r>
+          </a:p>
+        </p:txBody>
+      </p:sp>
+      <p:sp>
+        <p:nvSpPr>
+          <p:cNvPr id="8" name="Rectangle 7"/>
+          <p:cNvSpPr/>
+          <p:nvPr/>
+        </p:nvSpPr>
+        <p:spPr>
+          <a:xfrm>
+            <a:off x="8897112" y="960120"/>
+            <a:ext cx="2743200" cy="548640"/>
+          </a:xfrm>
+          <a:prstGeom prst="rect">
+            <a:avLst/>
+          </a:prstGeom>
+          <a:solidFill>
+            <a:srgbClr val="FFFFFF"/>
+          </a:solidFill>
+          <a:ln w="15875">
+            <a:solidFill>
+              <a:srgbClr val="E69F00"/>
+            </a:solidFill>
+          </a:ln>
+          <a:effectLst/>
+        </p:spPr>
+        <p:style>
+          <a:lnRef idx="1">
+            <a:schemeClr val="accent1"/>
+          </a:lnRef>
+          <a:fillRef idx="3">
+            <a:schemeClr val="accent1"/>
+          </a:fillRef>
+          <a:effectRef idx="2">
+            <a:schemeClr val="accent1"/>
+          </a:effectRef>
+          <a:fontRef idx="minor">
+            <a:schemeClr val="lt1"/>
+          </a:fontRef>
+        </p:style>
+        <p:txBody>
+          <a:bodyPr rtlCol="0" anchor="ctr"/>
+          <a:lstStyle/>
+          <a:p>
+            <a:pPr algn="ctr"/>
+          </a:p>
+        </p:txBody>
+      </p:sp>
+      <p:sp>
+        <p:nvSpPr>
+          <p:cNvPr id="9" name="TextBox 8"/>
+          <p:cNvSpPr txBox="1"/>
+          <p:nvPr/>
+        </p:nvSpPr>
+        <p:spPr>
+          <a:xfrm>
+            <a:off x="8988552" y="960120"/>
+            <a:ext cx="2606040" cy="548640"/>
+          </a:xfrm>
+          <a:prstGeom prst="rect">
+            <a:avLst/>
+          </a:prstGeom>
+          <a:noFill/>
+        </p:spPr>
+        <p:txBody>
+          <a:bodyPr wrap="square" lIns="0" rIns="0" tIns="0" bIns="0" anchor="ctr">
+            <a:spAutoFit/>
+          </a:bodyPr>
+          <a:lstStyle/>
+          <a:p>
+            <a:pPr algn="ctr"/>
+            <a:r>
+              <a:rPr sz="1000" b="1" i="0">
+                <a:solidFill>
+                  <a:srgbClr val="E69F00"/>
+                </a:solidFill>
+                <a:latin typeface="Calibri"/>
+              </a:rPr>
+              <a:t>28 trajectories  ·  7 phases</a:t>
+            </a:r>
+          </a:p>
+        </p:txBody>
+      </p:sp>
       <p:pic>
         <p:nvPicPr>
-          <p:cNvPr id="6" name="Picture 5" descr="method_04_prefix_preserving.png"/>
+          <p:cNvPr id="10" name="Picture 9" descr="method_04_prefix_preserving.png"/>
           <p:cNvPicPr>
             <a:picLocks noChangeAspect="1"/>
           </p:cNvPicPr>
@@ -7468,7 +9228,7 @@
         </p:blipFill>
         <p:spPr>
           <a:xfrm>
-            <a:off x="548640" y="1522894"/>
+            <a:off x="548640" y="1751494"/>
             <a:ext cx="11091672" cy="4452290"/>
           </a:xfrm>
           <a:prstGeom prst="rect">
@@ -7478,7 +9238,7 @@
       </p:pic>
       <p:sp>
         <p:nvSpPr>
-          <p:cNvPr id="7" name="TextBox 6"/>
+          <p:cNvPr id="11" name="TextBox 10"/>
           <p:cNvSpPr txBox="1"/>
           <p:nvPr/>
         </p:nvSpPr>
@@ -7513,7 +9273,7 @@
       </p:sp>
       <p:sp>
         <p:nvSpPr>
-          <p:cNvPr id="8" name="TextBox 7"/>
+          <p:cNvPr id="12" name="TextBox 11"/>
           <p:cNvSpPr txBox="1"/>
           <p:nvPr/>
         </p:nvSpPr>
@@ -7722,9 +9482,169 @@
           </a:p>
         </p:txBody>
       </p:sp>
+      <p:sp>
+        <p:nvSpPr>
+          <p:cNvPr id="6" name="Rectangle 5"/>
+          <p:cNvSpPr/>
+          <p:nvPr/>
+        </p:nvSpPr>
+        <p:spPr>
+          <a:xfrm>
+            <a:off x="548640" y="960120"/>
+            <a:ext cx="8229600" cy="548640"/>
+          </a:xfrm>
+          <a:prstGeom prst="rect">
+            <a:avLst/>
+          </a:prstGeom>
+          <a:solidFill>
+            <a:srgbClr val="1E3A8A"/>
+          </a:solidFill>
+          <a:ln>
+            <a:noFill/>
+          </a:ln>
+          <a:effectLst/>
+        </p:spPr>
+        <p:style>
+          <a:lnRef idx="1">
+            <a:schemeClr val="accent1"/>
+          </a:lnRef>
+          <a:fillRef idx="3">
+            <a:schemeClr val="accent1"/>
+          </a:fillRef>
+          <a:effectRef idx="2">
+            <a:schemeClr val="accent1"/>
+          </a:effectRef>
+          <a:fontRef idx="minor">
+            <a:schemeClr val="lt1"/>
+          </a:fontRef>
+        </p:style>
+        <p:txBody>
+          <a:bodyPr rtlCol="0" anchor="ctr"/>
+          <a:lstStyle/>
+          <a:p>
+            <a:pPr algn="ctr"/>
+          </a:p>
+        </p:txBody>
+      </p:sp>
+      <p:sp>
+        <p:nvSpPr>
+          <p:cNvPr id="7" name="TextBox 6"/>
+          <p:cNvSpPr txBox="1"/>
+          <p:nvPr/>
+        </p:nvSpPr>
+        <p:spPr>
+          <a:xfrm>
+            <a:off x="777240" y="960120"/>
+            <a:ext cx="7863840" cy="548640"/>
+          </a:xfrm>
+          <a:prstGeom prst="rect">
+            <a:avLst/>
+          </a:prstGeom>
+          <a:noFill/>
+        </p:spPr>
+        <p:txBody>
+          <a:bodyPr wrap="square" lIns="0" rIns="0" tIns="0" bIns="0" anchor="ctr">
+            <a:spAutoFit/>
+          </a:bodyPr>
+          <a:lstStyle/>
+          <a:p>
+            <a:pPr algn="l"/>
+            <a:r>
+              <a:rPr sz="1400" b="1" i="0">
+                <a:solidFill>
+                  <a:srgbClr val="FFFFFF"/>
+                </a:solidFill>
+                <a:latin typeface="Calibri"/>
+              </a:rPr>
+              <a:t>Proto-AdaptiveCache layout; no cost win at our scale</a:t>
+            </a:r>
+          </a:p>
+        </p:txBody>
+      </p:sp>
+      <p:sp>
+        <p:nvSpPr>
+          <p:cNvPr id="8" name="Rectangle 7"/>
+          <p:cNvSpPr/>
+          <p:nvPr/>
+        </p:nvSpPr>
+        <p:spPr>
+          <a:xfrm>
+            <a:off x="8897112" y="960120"/>
+            <a:ext cx="2743200" cy="548640"/>
+          </a:xfrm>
+          <a:prstGeom prst="rect">
+            <a:avLst/>
+          </a:prstGeom>
+          <a:solidFill>
+            <a:srgbClr val="FFFFFF"/>
+          </a:solidFill>
+          <a:ln w="15875">
+            <a:solidFill>
+              <a:srgbClr val="1E3A8A"/>
+            </a:solidFill>
+          </a:ln>
+          <a:effectLst/>
+        </p:spPr>
+        <p:style>
+          <a:lnRef idx="1">
+            <a:schemeClr val="accent1"/>
+          </a:lnRef>
+          <a:fillRef idx="3">
+            <a:schemeClr val="accent1"/>
+          </a:fillRef>
+          <a:effectRef idx="2">
+            <a:schemeClr val="accent1"/>
+          </a:effectRef>
+          <a:fontRef idx="minor">
+            <a:schemeClr val="lt1"/>
+          </a:fontRef>
+        </p:style>
+        <p:txBody>
+          <a:bodyPr rtlCol="0" anchor="ctr"/>
+          <a:lstStyle/>
+          <a:p>
+            <a:pPr algn="ctr"/>
+          </a:p>
+        </p:txBody>
+      </p:sp>
+      <p:sp>
+        <p:nvSpPr>
+          <p:cNvPr id="9" name="TextBox 8"/>
+          <p:cNvSpPr txBox="1"/>
+          <p:nvPr/>
+        </p:nvSpPr>
+        <p:spPr>
+          <a:xfrm>
+            <a:off x="8988552" y="960120"/>
+            <a:ext cx="2606040" cy="548640"/>
+          </a:xfrm>
+          <a:prstGeom prst="rect">
+            <a:avLst/>
+          </a:prstGeom>
+          <a:noFill/>
+        </p:spPr>
+        <p:txBody>
+          <a:bodyPr wrap="square" lIns="0" rIns="0" tIns="0" bIns="0" anchor="ctr">
+            <a:spAutoFit/>
+          </a:bodyPr>
+          <a:lstStyle/>
+          <a:p>
+            <a:pPr algn="ctr"/>
+            <a:r>
+              <a:rPr sz="1000" b="1" i="0">
+                <a:solidFill>
+                  <a:srgbClr val="1E3A8A"/>
+                </a:solidFill>
+                <a:latin typeface="Calibri"/>
+              </a:rPr>
+              <a:t>12 trajectories  ·  Phase A + C</a:t>
+            </a:r>
+          </a:p>
+        </p:txBody>
+      </p:sp>
       <p:pic>
         <p:nvPicPr>
-          <p:cNvPr id="6" name="Picture 5" descr="method_05_position_aware.png"/>
+          <p:cNvPr id="10" name="Picture 9" descr="method_05_position_aware.png"/>
           <p:cNvPicPr>
             <a:picLocks noChangeAspect="1"/>
           </p:cNvPicPr>
@@ -7738,7 +9658,7 @@
         </p:blipFill>
         <p:spPr>
           <a:xfrm>
-            <a:off x="548640" y="1900427"/>
+            <a:off x="548640" y="2129028"/>
             <a:ext cx="11091672" cy="3697224"/>
           </a:xfrm>
           <a:prstGeom prst="rect">
@@ -7748,7 +9668,7 @@
       </p:pic>
       <p:sp>
         <p:nvSpPr>
-          <p:cNvPr id="7" name="TextBox 6"/>
+          <p:cNvPr id="11" name="TextBox 10"/>
           <p:cNvSpPr txBox="1"/>
           <p:nvPr/>
         </p:nvSpPr>
@@ -7783,7 +9703,7 @@
       </p:sp>
       <p:sp>
         <p:nvSpPr>
-          <p:cNvPr id="8" name="TextBox 7"/>
+          <p:cNvPr id="12" name="TextBox 11"/>
           <p:cNvSpPr txBox="1"/>
           <p:nvPr/>
         </p:nvSpPr>

</xml_diff>